<commit_message>
Update tick scale and symbiotic food web
</commit_message>
<xml_diff>
--- a/Hydrosaltator_amictus_Presentation.pptx
+++ b/Hydrosaltator_amictus_Presentation.pptx
@@ -3313,7 +3313,7 @@
               </a:defRPr>
             </a:pPr>
             <a:r>
-              <a:t>0.3 mm total length — perfectly sized to maneuver through volcanic biofilms.</a:t>
+              <a:t>1 mm total length — perfectly sized to maneuver through volcanic biofilms.</a:t>
             </a:r>
           </a:p>
         </p:txBody>
@@ -4425,7 +4425,7 @@
               </a:defRPr>
             </a:pPr>
             <a:r>
-              <a:t>Reaches 0.3 mm. Spends life between 50°C and 85°C absorbing processed sugars.</a:t>
+              <a:t>Reaches 1 mm. Spends life between 50°C and 85°C absorbing processed sugars.</a:t>
             </a:r>
           </a:p>
         </p:txBody>

</xml_diff>

<commit_message>
Set tick size to 0.8 millimeters
</commit_message>
<xml_diff>
--- a/Hydrosaltator_amictus_Presentation.pptx
+++ b/Hydrosaltator_amictus_Presentation.pptx
@@ -3313,7 +3313,7 @@
               </a:defRPr>
             </a:pPr>
             <a:r>
-              <a:t>1 mm total length — perfectly sized to maneuver through volcanic biofilms.</a:t>
+              <a:t>0.8 mm total length — perfectly sized to maneuver through volcanic biofilms.</a:t>
             </a:r>
           </a:p>
         </p:txBody>
@@ -4425,7 +4425,7 @@
               </a:defRPr>
             </a:pPr>
             <a:r>
-              <a:t>Reaches 1 mm. Spends life between 50°C and 85°C absorbing processed sugars.</a:t>
+              <a:t>Reaches 0.8 mm. Spends life between 50°C and 85°C absorbing processed sugars.</a:t>
             </a:r>
           </a:p>
         </p:txBody>

</xml_diff>